<commit_message>
fixing case study 1
</commit_message>
<xml_diff>
--- a/figures/Figure2_case1.pptx
+++ b/figures/Figure2_case1.pptx
@@ -249,8 +249,11 @@
     </a:lvl9pPr>
   </p:defaultTextStyle>
   <p:extLst>
+    <p:ext uri="{EFAFB233-063F-42B5-8137-9DF3F51BA10A}">
+      <p15:sldGuideLst xmlns:p15="http://schemas.microsoft.com/office/powerpoint/2012/main"/>
+    </p:ext>
     <p:ext uri="GoogleSlidesCustomDataVersion2">
-      <go:slidesCustomData xmlns:go="http://customooxmlschemas.google.com/" xmlns:ahyp="http://schemas.microsoft.com/office/drawing/2018/hyperlinkcolor" xmlns:p15="http://schemas.microsoft.com/office/powerpoint/2012/main" xmlns:p14="http://schemas.microsoft.com/office/powerpoint/2010/main" xmlns:com="http://schemas.openxmlformats.org/drawingml/2006/compatibility" xmlns:pvml="urn:schemas-microsoft-com:office:powerpoint" xmlns:v="urn:schemas-microsoft-com:vml" xmlns:o="urn:schemas-microsoft-com:office:office" xmlns:dgm="http://schemas.openxmlformats.org/drawingml/2006/diagram" xmlns:c="http://schemas.openxmlformats.org/drawingml/2006/chart" xmlns:mv="urn:schemas-microsoft-com:mac:vml" xmlns:mc="http://schemas.openxmlformats.org/markup-compatibility/2006" xmlns="" r:id="rId8" roundtripDataSignature="AMtx7mgIxyl4bEzcNayDQ1Sc4BGs65vqzg=="/>
+      <go:slidesCustomData xmlns="" xmlns:mc="http://schemas.openxmlformats.org/markup-compatibility/2006" xmlns:mv="urn:schemas-microsoft-com:mac:vml" xmlns:c="http://schemas.openxmlformats.org/drawingml/2006/chart" xmlns:dgm="http://schemas.openxmlformats.org/drawingml/2006/diagram" xmlns:o="urn:schemas-microsoft-com:office:office" xmlns:v="urn:schemas-microsoft-com:vml" xmlns:pvml="urn:schemas-microsoft-com:office:powerpoint" xmlns:com="http://schemas.openxmlformats.org/drawingml/2006/compatibility" xmlns:p14="http://schemas.microsoft.com/office/powerpoint/2010/main" xmlns:p15="http://schemas.microsoft.com/office/powerpoint/2012/main" xmlns:ahyp="http://schemas.microsoft.com/office/drawing/2018/hyperlinkcolor" xmlns:go="http://customooxmlschemas.google.com/" r:id="rId8" roundtripDataSignature="AMtx7mgIxyl4bEzcNayDQ1Sc4BGs65vqzg=="/>
     </p:ext>
   </p:extLst>
 </p:presentation>
@@ -11993,7 +11996,7 @@
         </p:nvSpPr>
         <p:spPr>
           <a:xfrm>
-            <a:off x="5438823" y="4991967"/>
+            <a:off x="5585127" y="4991967"/>
             <a:ext cx="667265" cy="369332"/>
           </a:xfrm>
           <a:prstGeom prst="rect">
@@ -12121,36 +12124,6 @@
           </a:prstGeom>
         </p:spPr>
       </p:pic>
-      <p:pic>
-        <p:nvPicPr>
-          <p:cNvPr id="208" name="Picture 207">
-            <a:extLst>
-              <a:ext uri="{FF2B5EF4-FFF2-40B4-BE49-F238E27FC236}">
-                <a16:creationId xmlns:a16="http://schemas.microsoft.com/office/drawing/2014/main" id="{685CED16-FB0A-FD05-D756-241E85ABBB79}"/>
-              </a:ext>
-            </a:extLst>
-          </p:cNvPr>
-          <p:cNvPicPr>
-            <a:picLocks noChangeAspect="1"/>
-          </p:cNvPicPr>
-          <p:nvPr/>
-        </p:nvPicPr>
-        <p:blipFill>
-          <a:blip r:embed="rId6"/>
-          <a:stretch>
-            <a:fillRect/>
-          </a:stretch>
-        </p:blipFill>
-        <p:spPr>
-          <a:xfrm>
-            <a:off x="16858476" y="496812"/>
-            <a:ext cx="6262783" cy="4359039"/>
-          </a:xfrm>
-          <a:prstGeom prst="rect">
-            <a:avLst/>
-          </a:prstGeom>
-        </p:spPr>
-      </p:pic>
       <p:sp>
         <p:nvSpPr>
           <p:cNvPr id="210" name="Google Shape;99;p1">
@@ -12205,10 +12178,41 @@
       </p:sp>
       <p:pic>
         <p:nvPicPr>
-          <p:cNvPr id="211" name="Picture 210">
+          <p:cNvPr id="221" name="Picture 220">
             <a:extLst>
               <a:ext uri="{FF2B5EF4-FFF2-40B4-BE49-F238E27FC236}">
-                <a16:creationId xmlns:a16="http://schemas.microsoft.com/office/drawing/2014/main" id="{F6FFA1BD-3DDB-57A5-53A2-A8A239DEE397}"/>
+                <a16:creationId xmlns:a16="http://schemas.microsoft.com/office/drawing/2014/main" id="{46E43D71-B652-D83D-D673-B60F8A577D20}"/>
+              </a:ext>
+            </a:extLst>
+          </p:cNvPr>
+          <p:cNvPicPr>
+            <a:picLocks noChangeAspect="1"/>
+          </p:cNvPicPr>
+          <p:nvPr/>
+        </p:nvPicPr>
+        <p:blipFill>
+          <a:blip r:embed="rId6"/>
+          <a:srcRect l="2439"/>
+          <a:stretch>
+            <a:fillRect/>
+          </a:stretch>
+        </p:blipFill>
+        <p:spPr>
+          <a:xfrm>
+            <a:off x="-1" y="623635"/>
+            <a:ext cx="5598293" cy="9552492"/>
+          </a:xfrm>
+          <a:prstGeom prst="rect">
+            <a:avLst/>
+          </a:prstGeom>
+        </p:spPr>
+      </p:pic>
+      <p:pic>
+        <p:nvPicPr>
+          <p:cNvPr id="9" name="Picture 8">
+            <a:extLst>
+              <a:ext uri="{FF2B5EF4-FFF2-40B4-BE49-F238E27FC236}">
+                <a16:creationId xmlns:a16="http://schemas.microsoft.com/office/drawing/2014/main" id="{3E7890C6-34DD-F0FC-D3B0-F014713F57A7}"/>
               </a:ext>
             </a:extLst>
           </p:cNvPr>
@@ -12225,8 +12229,8 @@
         </p:blipFill>
         <p:spPr>
           <a:xfrm>
-            <a:off x="6106087" y="5176633"/>
-            <a:ext cx="7375445" cy="5301588"/>
+            <a:off x="16919740" y="245903"/>
+            <a:ext cx="6696475" cy="4660899"/>
           </a:xfrm>
           <a:prstGeom prst="rect">
             <a:avLst/>
@@ -12235,10 +12239,10 @@
       </p:pic>
       <p:pic>
         <p:nvPicPr>
-          <p:cNvPr id="217" name="Picture 216">
+          <p:cNvPr id="11" name="Picture 10">
             <a:extLst>
               <a:ext uri="{FF2B5EF4-FFF2-40B4-BE49-F238E27FC236}">
-                <a16:creationId xmlns:a16="http://schemas.microsoft.com/office/drawing/2014/main" id="{852A2F9E-B310-2A87-DFE1-842AA198E3D1}"/>
+                <a16:creationId xmlns:a16="http://schemas.microsoft.com/office/drawing/2014/main" id="{180715E3-DAE4-7427-21F5-1C8D02A7AED4}"/>
               </a:ext>
             </a:extLst>
           </p:cNvPr>
@@ -12255,8 +12259,8 @@
         </p:blipFill>
         <p:spPr>
           <a:xfrm>
-            <a:off x="14171344" y="5085864"/>
-            <a:ext cx="7579165" cy="5301588"/>
+            <a:off x="6308193" y="5176632"/>
+            <a:ext cx="6511550" cy="4660899"/>
           </a:xfrm>
           <a:prstGeom prst="rect">
             <a:avLst/>
@@ -12265,10 +12269,10 @@
       </p:pic>
       <p:pic>
         <p:nvPicPr>
-          <p:cNvPr id="221" name="Picture 220">
+          <p:cNvPr id="13" name="Picture 12">
             <a:extLst>
               <a:ext uri="{FF2B5EF4-FFF2-40B4-BE49-F238E27FC236}">
-                <a16:creationId xmlns:a16="http://schemas.microsoft.com/office/drawing/2014/main" id="{46E43D71-B652-D83D-D673-B60F8A577D20}"/>
+                <a16:creationId xmlns:a16="http://schemas.microsoft.com/office/drawing/2014/main" id="{2BC63EA0-8015-9BCC-71EB-4F5C09C65678}"/>
               </a:ext>
             </a:extLst>
           </p:cNvPr>
@@ -12279,15 +12283,14 @@
         </p:nvPicPr>
         <p:blipFill>
           <a:blip r:embed="rId9"/>
-          <a:srcRect l="2439"/>
           <a:stretch>
             <a:fillRect/>
           </a:stretch>
         </p:blipFill>
         <p:spPr>
           <a:xfrm>
-            <a:off x="-1" y="623635"/>
-            <a:ext cx="5598293" cy="9552492"/>
+            <a:off x="14598522" y="5176632"/>
+            <a:ext cx="6663233" cy="4660898"/>
           </a:xfrm>
           <a:prstGeom prst="rect">
             <a:avLst/>

</xml_diff>